<commit_message>
feat: WI-08 Foundry hosted agent scaffold + WI-09 staged-hybrid CI/CD
WI-08: agent manifest loader + runtime conformance (agent_manifests.py, GET /api/v1/agents, test_manifests.py); fixed orchestrator-manifest drift; docs/foundry-hosted-agent.md; .env.example placeholders. WI-09: GitHub Actions (ci, terraform-plan, terraform-apply), Stage-2 bootstrap scripts (remote state + OIDC), backend.tf.example, infra/DEPLOYMENT.md; terraform validated + fmt-clean.
</commit_message>
<xml_diff>
--- a/workshop-assets/foundry-phase2-build-addendum.pptx
+++ b/workshop-assets/foundry-phase2-build-addendum.pptx
@@ -11,9 +11,11 @@
     <p:sldId id="259" r:id="rId5"/>
     <p:sldId id="260" r:id="rId6"/>
     <p:sldId id="261" r:id="rId7"/>
+    <p:sldId id="262" r:id="rId8"/>
+    <p:sldId id="263" r:id="rId9"/>
   </p:sldIdLst>
   <p:notesMasterIdLst>
-    <p:notesMasterId r:id="rId8"/>
+    <p:notesMasterId r:id="rId10"/>
   </p:notesMasterIdLst>
   <p:sldSz cx="12192000" cy="6858000"/>
   <p:notesSz cx="6858000" cy="12192000"/>
@@ -971,6 +973,182 @@
             <a:fld id="{F7021451-1387-4CA6-816F-3879F97B5CBC}" type="slidenum">
               <a:rPr lang="en-US"/>
               <a:t>6</a:t>
+            </a:fld>
+            <a:endParaRPr lang="en-US"/>
+          </a:p>
+        </p:txBody>
+      </p:sp>
+    </p:spTree>
+    <p:extLst>
+      <p:ext uri="{BB962C8B-B14F-4D97-AF65-F5344CB8AC3E}">
+        <p14:creationId xmlns:p14="http://schemas.microsoft.com/office/powerpoint/2010/main" val="1024086991"/>
+      </p:ext>
+    </p:extLst>
+  </p:cSld>
+  <p:clrMapOvr>
+    <a:masterClrMapping/>
+  </p:clrMapOvr>
+</p:notes>
+</file>
+
+<file path=ppt/notesSlides/notesSlide7.xml><?xml version="1.0" encoding="utf-8"?>
+<p:notes xmlns:a="http://schemas.openxmlformats.org/drawingml/2006/main" xmlns:r="http://schemas.openxmlformats.org/officeDocument/2006/relationships" xmlns:p="http://schemas.openxmlformats.org/presentationml/2006/main">
+  <p:cSld>
+    <p:spTree>
+      <p:nvGrpSpPr>
+        <p:cNvPr id="1" name=""/>
+        <p:cNvGrpSpPr/>
+        <p:nvPr/>
+      </p:nvGrpSpPr>
+      <p:grpSpPr>
+        <a:xfrm>
+          <a:off x="0" y="0"/>
+          <a:ext cx="0" cy="0"/>
+          <a:chOff x="0" y="0"/>
+          <a:chExt cx="0" cy="0"/>
+        </a:xfrm>
+      </p:grpSpPr>
+      <p:sp>
+        <p:nvSpPr>
+          <p:cNvPr id="2" name="Slide Image Placeholder 1"/>
+          <p:cNvSpPr>
+            <a:spLocks noGrp="1" noRot="1" noChangeAspect="1"/>
+          </p:cNvSpPr>
+          <p:nvPr>
+            <p:ph type="sldImg"/>
+          </p:nvPr>
+        </p:nvSpPr>
+        <p:spPr/>
+      </p:sp>
+      <p:sp>
+        <p:nvSpPr>
+          <p:cNvPr id="3" name="Notes Placeholder 2"/>
+          <p:cNvSpPr>
+            <a:spLocks noGrp="1"/>
+          </p:cNvSpPr>
+          <p:nvPr>
+            <p:ph type="body" idx="1"/>
+          </p:nvPr>
+        </p:nvSpPr>
+        <p:spPr/>
+        <p:txBody>
+          <a:bodyPr/>
+          <a:lstStyle/>
+          <a:p>
+            <a:r>
+              <a:rPr lang="en-US" dirty="0"/>
+              <a:t>The prototype-to-production bridge. Same code, same contract, local or hosted. The conformance check keeps the declared agent design honest against the running code - it already caught a manifest that was missing a specialist. Governance point: managed identity, no keys, no secrets committed.</a:t>
+            </a:r>
+            <a:endParaRPr lang="en-US" dirty="0"/>
+          </a:p>
+        </p:txBody>
+      </p:sp>
+      <p:sp>
+        <p:nvSpPr>
+          <p:cNvPr id="4" name="Slide Number Placeholder 3"/>
+          <p:cNvSpPr>
+            <a:spLocks noGrp="1"/>
+          </p:cNvSpPr>
+          <p:nvPr>
+            <p:ph type="sldNum" sz="quarter" idx="10"/>
+          </p:nvPr>
+        </p:nvSpPr>
+        <p:spPr/>
+        <p:txBody>
+          <a:bodyPr/>
+          <a:lstStyle/>
+          <a:p>
+            <a:fld id="{F7021451-1387-4CA6-816F-3879F97B5CBC}" type="slidenum">
+              <a:rPr lang="en-US"/>
+              <a:t>7</a:t>
+            </a:fld>
+            <a:endParaRPr lang="en-US"/>
+          </a:p>
+        </p:txBody>
+      </p:sp>
+    </p:spTree>
+    <p:extLst>
+      <p:ext uri="{BB962C8B-B14F-4D97-AF65-F5344CB8AC3E}">
+        <p14:creationId xmlns:p14="http://schemas.microsoft.com/office/powerpoint/2010/main" val="1024086991"/>
+      </p:ext>
+    </p:extLst>
+  </p:cSld>
+  <p:clrMapOvr>
+    <a:masterClrMapping/>
+  </p:clrMapOvr>
+</p:notes>
+</file>
+
+<file path=ppt/notesSlides/notesSlide8.xml><?xml version="1.0" encoding="utf-8"?>
+<p:notes xmlns:a="http://schemas.openxmlformats.org/drawingml/2006/main" xmlns:r="http://schemas.openxmlformats.org/officeDocument/2006/relationships" xmlns:p="http://schemas.openxmlformats.org/presentationml/2006/main">
+  <p:cSld>
+    <p:spTree>
+      <p:nvGrpSpPr>
+        <p:cNvPr id="1" name=""/>
+        <p:cNvGrpSpPr/>
+        <p:nvPr/>
+      </p:nvGrpSpPr>
+      <p:grpSpPr>
+        <a:xfrm>
+          <a:off x="0" y="0"/>
+          <a:ext cx="0" cy="0"/>
+          <a:chOff x="0" y="0"/>
+          <a:chExt cx="0" cy="0"/>
+        </a:xfrm>
+      </p:grpSpPr>
+      <p:sp>
+        <p:nvSpPr>
+          <p:cNvPr id="2" name="Slide Image Placeholder 1"/>
+          <p:cNvSpPr>
+            <a:spLocks noGrp="1" noRot="1" noChangeAspect="1"/>
+          </p:cNvSpPr>
+          <p:nvPr>
+            <p:ph type="sldImg"/>
+          </p:nvPr>
+        </p:nvSpPr>
+        <p:spPr/>
+      </p:sp>
+      <p:sp>
+        <p:nvSpPr>
+          <p:cNvPr id="3" name="Notes Placeholder 2"/>
+          <p:cNvSpPr>
+            <a:spLocks noGrp="1"/>
+          </p:cNvSpPr>
+          <p:nvPr>
+            <p:ph type="body" idx="1"/>
+          </p:nvPr>
+        </p:nvSpPr>
+        <p:spPr/>
+        <p:txBody>
+          <a:bodyPr/>
+          <a:lstStyle/>
+          <a:p>
+            <a:r>
+              <a:rPr lang="en-US" dirty="0"/>
+              <a:t>The prototype-to-production pipeline. Emphasize the chicken-and-egg: remote state + OIDC must exist before CI, so there is always a one-time local bootstrap. The money story for DevOps: PR -&gt; plan diff -&gt; approve -&gt; gated apply, no stored credentials. For a workshop you can keep plan-only and apply manually.</a:t>
+            </a:r>
+            <a:endParaRPr lang="en-US" dirty="0"/>
+          </a:p>
+        </p:txBody>
+      </p:sp>
+      <p:sp>
+        <p:nvSpPr>
+          <p:cNvPr id="4" name="Slide Number Placeholder 3"/>
+          <p:cNvSpPr>
+            <a:spLocks noGrp="1"/>
+          </p:cNvSpPr>
+          <p:nvPr>
+            <p:ph type="sldNum" sz="quarter" idx="10"/>
+          </p:nvPr>
+        </p:nvSpPr>
+        <p:spPr/>
+        <p:txBody>
+          <a:bodyPr/>
+          <a:lstStyle/>
+          <a:p>
+            <a:fld id="{F7021451-1387-4CA6-816F-3879F97B5CBC}" type="slidenum">
+              <a:rPr lang="en-US"/>
+              <a:t>8</a:t>
             </a:fld>
             <a:endParaRPr lang="en-US"/>
           </a:p>
@@ -5490,6 +5668,1478 @@
             <a:fld id="{F7021451-1387-4CA6-816F-3879F97B5CBC}" type="slidenum">
               <a:rPr b="0" lang="en-US"/>
               <a:t>6</a:t>
+            </a:fld>
+            <a:endParaRPr lang="en-US"/>
+          </a:p>
+        </p:txBody>
+      </p:sp>
+    </p:spTree>
+  </p:cSld>
+  <p:clrMapOvr>
+    <a:masterClrMapping/>
+  </p:clrMapOvr>
+</p:sld>
+</file>
+
+<file path=ppt/slides/slide7.xml><?xml version="1.0" encoding="utf-8"?>
+<p:sld xmlns:a="http://schemas.openxmlformats.org/drawingml/2006/main" xmlns:r="http://schemas.openxmlformats.org/officeDocument/2006/relationships" xmlns:p="http://schemas.openxmlformats.org/presentationml/2006/main">
+  <p:cSld name="Slide 7">
+    <p:bg>
+      <p:bgPr>
+        <a:solidFill>
+          <a:srgbClr val="F8FAFC"/>
+        </a:solidFill>
+      </p:bgPr>
+    </p:bg>
+    <p:spTree>
+      <p:nvGrpSpPr>
+        <p:cNvPr id="1" name=""/>
+        <p:cNvGrpSpPr/>
+        <p:nvPr/>
+      </p:nvGrpSpPr>
+      <p:grpSpPr>
+        <a:xfrm>
+          <a:off x="0" y="0"/>
+          <a:ext cx="0" cy="0"/>
+          <a:chOff x="0" y="0"/>
+          <a:chExt cx="0" cy="0"/>
+        </a:xfrm>
+      </p:grpSpPr>
+      <p:sp>
+        <p:nvSpPr>
+          <p:cNvPr id="2" name="Text 0"/>
+          <p:cNvSpPr/>
+          <p:nvPr/>
+        </p:nvSpPr>
+        <p:spPr>
+          <a:xfrm>
+            <a:off x="566928" y="384048"/>
+            <a:ext cx="8686800" cy="201168"/>
+          </a:xfrm>
+          <a:prstGeom prst="rect">
+            <a:avLst/>
+          </a:prstGeom>
+          <a:noFill/>
+          <a:ln/>
+        </p:spPr>
+        <p:txBody>
+          <a:bodyPr wrap="square" lIns="0" tIns="0" rIns="0" bIns="0" rtlCol="0" anchor="ctr"/>
+          <a:lstStyle/>
+          <a:p>
+            <a:pPr indent="0" marL="0">
+              <a:buNone/>
+            </a:pPr>
+            <a:r>
+              <a:rPr lang="en-US" sz="800" b="1" dirty="0">
+                <a:solidFill>
+                  <a:srgbClr val="0F766E"/>
+                </a:solidFill>
+                <a:latin typeface="Aptos" pitchFamily="34" charset="0"/>
+                <a:ea typeface="Aptos" pitchFamily="34" charset="-122"/>
+                <a:cs typeface="Aptos" pitchFamily="34" charset="-120"/>
+              </a:rPr>
+              <a:t>WI-08 - PROTOTYPE TO PRODUCTION</a:t>
+            </a:r>
+            <a:endParaRPr lang="en-US" sz="800" dirty="0"/>
+          </a:p>
+        </p:txBody>
+      </p:sp>
+      <p:sp>
+        <p:nvSpPr>
+          <p:cNvPr id="3" name="Text 1"/>
+          <p:cNvSpPr/>
+          <p:nvPr/>
+        </p:nvSpPr>
+        <p:spPr>
+          <a:xfrm>
+            <a:off x="548640" y="658368"/>
+            <a:ext cx="10972800" cy="502920"/>
+          </a:xfrm>
+          <a:prstGeom prst="rect">
+            <a:avLst/>
+          </a:prstGeom>
+          <a:noFill/>
+          <a:ln/>
+        </p:spPr>
+        <p:txBody>
+          <a:bodyPr wrap="square" lIns="0" tIns="0" rIns="0" bIns="0" rtlCol="0" anchor="ctr">
+            <a:normAutofit/>
+          </a:bodyPr>
+          <a:lstStyle/>
+          <a:p>
+            <a:pPr indent="0" marL="0">
+              <a:buNone/>
+            </a:pPr>
+            <a:r>
+              <a:rPr lang="en-US" sz="2400" b="1" dirty="0">
+                <a:solidFill>
+                  <a:srgbClr val="0B1220"/>
+                </a:solidFill>
+                <a:latin typeface="Aptos Display" pitchFamily="34" charset="0"/>
+                <a:ea typeface="Aptos Display" pitchFamily="34" charset="-122"/>
+                <a:cs typeface="Aptos Display" pitchFamily="34" charset="-120"/>
+              </a:rPr>
+              <a:t>Foundry hosted agent + manifest conformance</a:t>
+            </a:r>
+            <a:endParaRPr lang="en-US" sz="2400" dirty="0"/>
+          </a:p>
+        </p:txBody>
+      </p:sp>
+      <p:sp>
+        <p:nvSpPr>
+          <p:cNvPr id="4" name="Shape 2"/>
+          <p:cNvSpPr/>
+          <p:nvPr/>
+        </p:nvSpPr>
+        <p:spPr>
+          <a:xfrm>
+            <a:off x="548640" y="1243584"/>
+            <a:ext cx="11064240" cy="0"/>
+          </a:xfrm>
+          <a:prstGeom prst="line">
+            <a:avLst/>
+          </a:prstGeom>
+          <a:noFill/>
+          <a:ln w="12700">
+            <a:solidFill>
+              <a:srgbClr val="CBD5E1"/>
+            </a:solidFill>
+            <a:prstDash val="solid"/>
+          </a:ln>
+        </p:spPr>
+      </p:sp>
+      <p:sp>
+        <p:nvSpPr>
+          <p:cNvPr id="5" name="Shape 3"/>
+          <p:cNvSpPr/>
+          <p:nvPr/>
+        </p:nvSpPr>
+        <p:spPr>
+          <a:xfrm>
+            <a:off x="640080" y="1463040"/>
+            <a:ext cx="3520440" cy="1874520"/>
+          </a:xfrm>
+          <a:prstGeom prst="roundRect">
+            <a:avLst>
+              <a:gd name="adj" fmla="val 3902"/>
+            </a:avLst>
+          </a:prstGeom>
+          <a:solidFill>
+            <a:srgbClr val="FFFFFF"/>
+          </a:solidFill>
+          <a:ln w="12700">
+            <a:solidFill>
+              <a:srgbClr val="E2E8F0"/>
+            </a:solidFill>
+            <a:prstDash val="solid"/>
+          </a:ln>
+          <a:effectLst>
+            <a:outerShdw sx="100000" sy="100000" kx="0" ky="0" algn="bl" rotWithShape="0" blurRad="25400" dist="50800" dir="2700000">
+              <a:srgbClr val="94A3B8">
+                <a:alpha val="12000"/>
+              </a:srgbClr>
+            </a:outerShdw>
+          </a:effectLst>
+        </p:spPr>
+      </p:sp>
+      <p:sp>
+        <p:nvSpPr>
+          <p:cNvPr id="6" name="Shape 4"/>
+          <p:cNvSpPr/>
+          <p:nvPr/>
+        </p:nvSpPr>
+        <p:spPr>
+          <a:xfrm>
+            <a:off x="640080" y="1463040"/>
+            <a:ext cx="64008" cy="1874520"/>
+          </a:xfrm>
+          <a:prstGeom prst="rect">
+            <a:avLst/>
+          </a:prstGeom>
+          <a:solidFill>
+            <a:srgbClr val="7C3AED"/>
+          </a:solidFill>
+          <a:ln w="12700">
+            <a:solidFill>
+              <a:srgbClr val="7C3AED"/>
+            </a:solidFill>
+            <a:prstDash val="solid"/>
+          </a:ln>
+        </p:spPr>
+      </p:sp>
+      <p:sp>
+        <p:nvSpPr>
+          <p:cNvPr id="7" name="Text 5"/>
+          <p:cNvSpPr/>
+          <p:nvPr/>
+        </p:nvSpPr>
+        <p:spPr>
+          <a:xfrm>
+            <a:off x="841248" y="1609344"/>
+            <a:ext cx="3200400" cy="219456"/>
+          </a:xfrm>
+          <a:prstGeom prst="rect">
+            <a:avLst/>
+          </a:prstGeom>
+          <a:noFill/>
+          <a:ln/>
+        </p:spPr>
+        <p:txBody>
+          <a:bodyPr wrap="square" lIns="0" tIns="0" rIns="0" bIns="0" rtlCol="0" anchor="ctr">
+            <a:normAutofit/>
+          </a:bodyPr>
+          <a:lstStyle/>
+          <a:p>
+            <a:pPr indent="0" marL="0">
+              <a:buNone/>
+            </a:pPr>
+            <a:r>
+              <a:rPr lang="en-US" sz="1200" b="1" dirty="0">
+                <a:solidFill>
+                  <a:srgbClr val="0B1220"/>
+                </a:solidFill>
+                <a:latin typeface="Aptos" pitchFamily="34" charset="0"/>
+                <a:ea typeface="Aptos" pitchFamily="34" charset="-122"/>
+                <a:cs typeface="Aptos" pitchFamily="34" charset="-120"/>
+              </a:rPr>
+              <a:t>Same contract, two homes</a:t>
+            </a:r>
+            <a:endParaRPr lang="en-US" sz="1200" dirty="0"/>
+          </a:p>
+        </p:txBody>
+      </p:sp>
+      <p:sp>
+        <p:nvSpPr>
+          <p:cNvPr id="8" name="Text 6"/>
+          <p:cNvSpPr/>
+          <p:nvPr/>
+        </p:nvSpPr>
+        <p:spPr>
+          <a:xfrm>
+            <a:off x="841248" y="1920240"/>
+            <a:ext cx="3200400" cy="1325880"/>
+          </a:xfrm>
+          <a:prstGeom prst="rect">
+            <a:avLst/>
+          </a:prstGeom>
+          <a:noFill/>
+          <a:ln/>
+        </p:spPr>
+        <p:txBody>
+          <a:bodyPr wrap="square" lIns="254" tIns="254" rIns="254" bIns="254" rtlCol="0" anchor="t">
+            <a:normAutofit/>
+          </a:bodyPr>
+          <a:lstStyle/>
+          <a:p>
+            <a:pPr indent="0" marL="0">
+              <a:buNone/>
+            </a:pPr>
+            <a:r>
+              <a:rPr lang="en-US" sz="920" dirty="0">
+                <a:solidFill>
+                  <a:srgbClr val="334155"/>
+                </a:solidFill>
+                <a:latin typeface="Aptos" pitchFamily="34" charset="0"/>
+                <a:ea typeface="Aptos" pitchFamily="34" charset="-122"/>
+                <a:cs typeface="Aptos" pitchFamily="34" charset="-120"/>
+              </a:rPr>
+              <a:t>The code-first agent service runs locally (deterministic, offline) and deploys as a Foundry hosted agent - the POST /api/v1/agent/invoke contract does not change. The local orchestrator stays the offline fallback.</a:t>
+            </a:r>
+            <a:endParaRPr lang="en-US" sz="920" dirty="0"/>
+          </a:p>
+        </p:txBody>
+      </p:sp>
+      <p:sp>
+        <p:nvSpPr>
+          <p:cNvPr id="9" name="Shape 7"/>
+          <p:cNvSpPr/>
+          <p:nvPr/>
+        </p:nvSpPr>
+        <p:spPr>
+          <a:xfrm>
+            <a:off x="4343400" y="1463040"/>
+            <a:ext cx="3520440" cy="1874520"/>
+          </a:xfrm>
+          <a:prstGeom prst="roundRect">
+            <a:avLst>
+              <a:gd name="adj" fmla="val 3902"/>
+            </a:avLst>
+          </a:prstGeom>
+          <a:solidFill>
+            <a:srgbClr val="FFFFFF"/>
+          </a:solidFill>
+          <a:ln w="12700">
+            <a:solidFill>
+              <a:srgbClr val="E2E8F0"/>
+            </a:solidFill>
+            <a:prstDash val="solid"/>
+          </a:ln>
+          <a:effectLst>
+            <a:outerShdw sx="100000" sy="100000" kx="0" ky="0" algn="bl" rotWithShape="0" blurRad="25400" dist="50800" dir="2700000">
+              <a:srgbClr val="94A3B8">
+                <a:alpha val="12000"/>
+              </a:srgbClr>
+            </a:outerShdw>
+          </a:effectLst>
+        </p:spPr>
+      </p:sp>
+      <p:sp>
+        <p:nvSpPr>
+          <p:cNvPr id="10" name="Shape 8"/>
+          <p:cNvSpPr/>
+          <p:nvPr/>
+        </p:nvSpPr>
+        <p:spPr>
+          <a:xfrm>
+            <a:off x="4343400" y="1463040"/>
+            <a:ext cx="64008" cy="1874520"/>
+          </a:xfrm>
+          <a:prstGeom prst="rect">
+            <a:avLst/>
+          </a:prstGeom>
+          <a:solidFill>
+            <a:srgbClr val="0F766E"/>
+          </a:solidFill>
+          <a:ln w="12700">
+            <a:solidFill>
+              <a:srgbClr val="0F766E"/>
+            </a:solidFill>
+            <a:prstDash val="solid"/>
+          </a:ln>
+        </p:spPr>
+      </p:sp>
+      <p:sp>
+        <p:nvSpPr>
+          <p:cNvPr id="11" name="Text 9"/>
+          <p:cNvSpPr/>
+          <p:nvPr/>
+        </p:nvSpPr>
+        <p:spPr>
+          <a:xfrm>
+            <a:off x="4544568" y="1609344"/>
+            <a:ext cx="3200400" cy="219456"/>
+          </a:xfrm>
+          <a:prstGeom prst="rect">
+            <a:avLst/>
+          </a:prstGeom>
+          <a:noFill/>
+          <a:ln/>
+        </p:spPr>
+        <p:txBody>
+          <a:bodyPr wrap="square" lIns="0" tIns="0" rIns="0" bIns="0" rtlCol="0" anchor="ctr">
+            <a:normAutofit/>
+          </a:bodyPr>
+          <a:lstStyle/>
+          <a:p>
+            <a:pPr indent="0" marL="0">
+              <a:buNone/>
+            </a:pPr>
+            <a:r>
+              <a:rPr lang="en-US" sz="1200" b="1" dirty="0">
+                <a:solidFill>
+                  <a:srgbClr val="0B1220"/>
+                </a:solidFill>
+                <a:latin typeface="Aptos" pitchFamily="34" charset="0"/>
+                <a:ea typeface="Aptos" pitchFamily="34" charset="-122"/>
+                <a:cs typeface="Aptos" pitchFamily="34" charset="-120"/>
+              </a:rPr>
+              <a:t>Declared == running</a:t>
+            </a:r>
+            <a:endParaRPr lang="en-US" sz="1200" dirty="0"/>
+          </a:p>
+        </p:txBody>
+      </p:sp>
+      <p:sp>
+        <p:nvSpPr>
+          <p:cNvPr id="12" name="Text 10"/>
+          <p:cNvSpPr/>
+          <p:nvPr/>
+        </p:nvSpPr>
+        <p:spPr>
+          <a:xfrm>
+            <a:off x="4544568" y="1920240"/>
+            <a:ext cx="3200400" cy="1325880"/>
+          </a:xfrm>
+          <a:prstGeom prst="rect">
+            <a:avLst/>
+          </a:prstGeom>
+          <a:noFill/>
+          <a:ln/>
+        </p:spPr>
+        <p:txBody>
+          <a:bodyPr wrap="square" lIns="254" tIns="254" rIns="254" bIns="254" rtlCol="0" anchor="t">
+            <a:normAutofit/>
+          </a:bodyPr>
+          <a:lstStyle/>
+          <a:p>
+            <a:pPr indent="0" marL="0">
+              <a:buNone/>
+            </a:pPr>
+            <a:r>
+              <a:rPr lang="en-US" sz="920" dirty="0">
+                <a:solidFill>
+                  <a:srgbClr val="334155"/>
+                </a:solidFill>
+                <a:latin typeface="Aptos" pitchFamily="34" charset="0"/>
+                <a:ea typeface="Aptos" pitchFamily="34" charset="-122"/>
+                <a:cs typeface="Aptos" pitchFamily="34" charset="-120"/>
+              </a:rPr>
+              <a:t>The 7 specialists are declared in agents/*.yaml. agent_manifests.py checks the manifests match the running orchestrator; GET /api/v1/agents reports the set and any drift. It caught a real gap: a missing specialist in the orchestrator manifest.</a:t>
+            </a:r>
+            <a:endParaRPr lang="en-US" sz="920" dirty="0"/>
+          </a:p>
+        </p:txBody>
+      </p:sp>
+      <p:sp>
+        <p:nvSpPr>
+          <p:cNvPr id="13" name="Shape 11"/>
+          <p:cNvSpPr/>
+          <p:nvPr/>
+        </p:nvSpPr>
+        <p:spPr>
+          <a:xfrm>
+            <a:off x="8046720" y="1463040"/>
+            <a:ext cx="3520440" cy="1874520"/>
+          </a:xfrm>
+          <a:prstGeom prst="roundRect">
+            <a:avLst>
+              <a:gd name="adj" fmla="val 3902"/>
+            </a:avLst>
+          </a:prstGeom>
+          <a:solidFill>
+            <a:srgbClr val="FFFFFF"/>
+          </a:solidFill>
+          <a:ln w="12700">
+            <a:solidFill>
+              <a:srgbClr val="E2E8F0"/>
+            </a:solidFill>
+            <a:prstDash val="solid"/>
+          </a:ln>
+          <a:effectLst>
+            <a:outerShdw sx="100000" sy="100000" kx="0" ky="0" algn="bl" rotWithShape="0" blurRad="25400" dist="50800" dir="2700000">
+              <a:srgbClr val="94A3B8">
+                <a:alpha val="12000"/>
+              </a:srgbClr>
+            </a:outerShdw>
+          </a:effectLst>
+        </p:spPr>
+      </p:sp>
+      <p:sp>
+        <p:nvSpPr>
+          <p:cNvPr id="14" name="Shape 12"/>
+          <p:cNvSpPr/>
+          <p:nvPr/>
+        </p:nvSpPr>
+        <p:spPr>
+          <a:xfrm>
+            <a:off x="8046720" y="1463040"/>
+            <a:ext cx="64008" cy="1874520"/>
+          </a:xfrm>
+          <a:prstGeom prst="rect">
+            <a:avLst/>
+          </a:prstGeom>
+          <a:solidFill>
+            <a:srgbClr val="16A34A"/>
+          </a:solidFill>
+          <a:ln w="12700">
+            <a:solidFill>
+              <a:srgbClr val="16A34A"/>
+            </a:solidFill>
+            <a:prstDash val="solid"/>
+          </a:ln>
+        </p:spPr>
+      </p:sp>
+      <p:sp>
+        <p:nvSpPr>
+          <p:cNvPr id="15" name="Text 13"/>
+          <p:cNvSpPr/>
+          <p:nvPr/>
+        </p:nvSpPr>
+        <p:spPr>
+          <a:xfrm>
+            <a:off x="8247888" y="1609344"/>
+            <a:ext cx="3200400" cy="219456"/>
+          </a:xfrm>
+          <a:prstGeom prst="rect">
+            <a:avLst/>
+          </a:prstGeom>
+          <a:noFill/>
+          <a:ln/>
+        </p:spPr>
+        <p:txBody>
+          <a:bodyPr wrap="square" lIns="0" tIns="0" rIns="0" bIns="0" rtlCol="0" anchor="ctr">
+            <a:normAutofit/>
+          </a:bodyPr>
+          <a:lstStyle/>
+          <a:p>
+            <a:pPr indent="0" marL="0">
+              <a:buNone/>
+            </a:pPr>
+            <a:r>
+              <a:rPr lang="en-US" sz="1200" b="1" dirty="0">
+                <a:solidFill>
+                  <a:srgbClr val="0B1220"/>
+                </a:solidFill>
+                <a:latin typeface="Aptos" pitchFamily="34" charset="0"/>
+                <a:ea typeface="Aptos" pitchFamily="34" charset="-122"/>
+                <a:cs typeface="Aptos" pitchFamily="34" charset="-120"/>
+              </a:rPr>
+              <a:t>No keys, RBAC only</a:t>
+            </a:r>
+            <a:endParaRPr lang="en-US" sz="1200" dirty="0"/>
+          </a:p>
+        </p:txBody>
+      </p:sp>
+      <p:sp>
+        <p:nvSpPr>
+          <p:cNvPr id="16" name="Text 14"/>
+          <p:cNvSpPr/>
+          <p:nvPr/>
+        </p:nvSpPr>
+        <p:spPr>
+          <a:xfrm>
+            <a:off x="8247888" y="1920240"/>
+            <a:ext cx="3200400" cy="1325880"/>
+          </a:xfrm>
+          <a:prstGeom prst="rect">
+            <a:avLst/>
+          </a:prstGeom>
+          <a:noFill/>
+          <a:ln/>
+        </p:spPr>
+        <p:txBody>
+          <a:bodyPr wrap="square" lIns="254" tIns="254" rIns="254" bIns="254" rtlCol="0" anchor="t">
+            <a:normAutofit/>
+          </a:bodyPr>
+          <a:lstStyle/>
+          <a:p>
+            <a:pPr indent="0" marL="0">
+              <a:buNone/>
+            </a:pPr>
+            <a:r>
+              <a:rPr lang="en-US" sz="920" dirty="0">
+                <a:solidFill>
+                  <a:srgbClr val="334155"/>
+                </a:solidFill>
+                <a:latin typeface="Aptos" pitchFamily="34" charset="0"/>
+                <a:ea typeface="Aptos" pitchFamily="34" charset="-122"/>
+                <a:cs typeface="Aptos" pitchFamily="34" charset="-120"/>
+              </a:rPr>
+              <a:t>The model is reached with managed identity (DefaultAzureCredential); there are no API keys in the repo or the deployed app. .env is gitignored; .env.example holds placeholders only.</a:t>
+            </a:r>
+            <a:endParaRPr lang="en-US" sz="920" dirty="0"/>
+          </a:p>
+        </p:txBody>
+      </p:sp>
+      <p:sp>
+        <p:nvSpPr>
+          <p:cNvPr id="17" name="Text 15"/>
+          <p:cNvSpPr/>
+          <p:nvPr/>
+        </p:nvSpPr>
+        <p:spPr>
+          <a:xfrm>
+            <a:off x="640080" y="3520440"/>
+            <a:ext cx="10972800" cy="1097280"/>
+          </a:xfrm>
+          <a:prstGeom prst="rect">
+            <a:avLst/>
+          </a:prstGeom>
+          <a:noFill/>
+          <a:ln/>
+        </p:spPr>
+        <p:txBody>
+          <a:bodyPr wrap="square" lIns="381" tIns="381" rIns="381" bIns="381" rtlCol="0" anchor="ctr">
+            <a:normAutofit/>
+          </a:bodyPr>
+          <a:lstStyle/>
+          <a:p>
+            <a:pPr marL="152400" indent="-152400">
+              <a:buSzPct val="100000"/>
+              <a:buChar char="•"/>
+            </a:pPr>
+            <a:r>
+              <a:rPr lang="en-US" sz="1150" dirty="0">
+                <a:solidFill>
+                  <a:srgbClr val="334155"/>
+                </a:solidFill>
+                <a:latin typeface="Aptos" pitchFamily="34" charset="0"/>
+                <a:ea typeface="Aptos" pitchFamily="34" charset="-122"/>
+                <a:cs typeface="Aptos" pitchFamily="34" charset="-120"/>
+              </a:rPr>
+              <a:t>Deploy paths: container sidecar (Terraform, implemented) or azd hosted agent (azure.yaml). Guide: docs/foundry-hosted-agent.md.</a:t>
+            </a:r>
+            <a:endParaRPr lang="en-US" sz="1150" dirty="0"/>
+          </a:p>
+          <a:p>
+            <a:pPr marL="152400" indent="-152400">
+              <a:buSzPct val="100000"/>
+              <a:buChar char="•"/>
+            </a:pPr>
+            <a:r>
+              <a:rPr lang="en-US" sz="1150" dirty="0">
+                <a:solidFill>
+                  <a:srgbClr val="334155"/>
+                </a:solidFill>
+                <a:latin typeface="Aptos" pitchFamily="34" charset="0"/>
+                <a:ea typeface="Aptos" pitchFamily="34" charset="-122"/>
+                <a:cs typeface="Aptos" pitchFamily="34" charset="-120"/>
+              </a:rPr>
+              <a:t>The model only refines draft wording - never generates a risk score, makes a determination, or bypasses human review.</a:t>
+            </a:r>
+            <a:endParaRPr lang="en-US" sz="1150" dirty="0"/>
+          </a:p>
+        </p:txBody>
+      </p:sp>
+      <p:sp>
+        <p:nvSpPr>
+          <p:cNvPr id="18" name="Shape 16"/>
+          <p:cNvSpPr/>
+          <p:nvPr/>
+        </p:nvSpPr>
+        <p:spPr>
+          <a:xfrm>
+            <a:off x="640080" y="4709160"/>
+            <a:ext cx="10972800" cy="914400"/>
+          </a:xfrm>
+          <a:prstGeom prst="roundRect">
+            <a:avLst>
+              <a:gd name="adj" fmla="val 6000"/>
+            </a:avLst>
+          </a:prstGeom>
+          <a:solidFill>
+            <a:srgbClr val="0B1220"/>
+          </a:solidFill>
+          <a:ln w="12700">
+            <a:solidFill>
+              <a:srgbClr val="1E293B"/>
+            </a:solidFill>
+            <a:prstDash val="solid"/>
+          </a:ln>
+        </p:spPr>
+      </p:sp>
+      <p:sp>
+        <p:nvSpPr>
+          <p:cNvPr id="19" name="Text 17"/>
+          <p:cNvSpPr/>
+          <p:nvPr/>
+        </p:nvSpPr>
+        <p:spPr>
+          <a:xfrm>
+            <a:off x="777240" y="4818888"/>
+            <a:ext cx="10698480" cy="694944"/>
+          </a:xfrm>
+          <a:prstGeom prst="rect">
+            <a:avLst/>
+          </a:prstGeom>
+          <a:noFill/>
+          <a:ln/>
+        </p:spPr>
+        <p:txBody>
+          <a:bodyPr wrap="square" lIns="0" tIns="0" rIns="0" bIns="0" rtlCol="0" anchor="t"/>
+          <a:lstStyle/>
+          <a:p>
+            <a:pPr indent="0" marL="0">
+              <a:buNone/>
+            </a:pPr>
+            <a:r>
+              <a:rPr lang="en-US" sz="900" dirty="0">
+                <a:solidFill>
+                  <a:srgbClr val="CBD5E1"/>
+                </a:solidFill>
+                <a:latin typeface="Consolas" pitchFamily="34" charset="0"/>
+                <a:ea typeface="Consolas" pitchFamily="34" charset="-122"/>
+                <a:cs typeface="Consolas" pitchFamily="34" charset="-120"/>
+              </a:rPr>
+              <a:t>GET /api/v1/agents   -&gt;  7 specialists,  issues: []   (conformant)</a:t>
+            </a:r>
+            <a:endParaRPr lang="en-US" sz="900" dirty="0"/>
+          </a:p>
+          <a:p>
+            <a:pPr indent="0" marL="0">
+              <a:buNone/>
+            </a:pPr>
+            <a:r>
+              <a:rPr lang="en-US" sz="900" dirty="0">
+                <a:solidFill>
+                  <a:srgbClr val="CBD5E1"/>
+                </a:solidFill>
+                <a:latin typeface="Consolas" pitchFamily="34" charset="0"/>
+                <a:ea typeface="Consolas" pitchFamily="34" charset="-122"/>
+                <a:cs typeface="Consolas" pitchFamily="34" charset="-120"/>
+              </a:rPr>
+              <a:t>tests/test_manifests.py                              PASS</a:t>
+            </a:r>
+            <a:endParaRPr lang="en-US" sz="900" dirty="0"/>
+          </a:p>
+        </p:txBody>
+      </p:sp>
+      <p:sp>
+        <p:nvSpPr>
+          <p:cNvPr id="25" name="Slide Number Placeholder 0"/>
+          <p:cNvSpPr>
+            <a:spLocks noGrp="1"/>
+          </p:cNvSpPr>
+          <p:nvPr>
+            <p:ph type="sldNum" sz="quarter" idx="4294967295"/>
+          </p:nvPr>
+        </p:nvSpPr>
+        <p:spPr>
+          <a:xfrm>
+            <a:off x="11475720" y="6565392"/>
+            <a:ext cx="800000" cy="300000"/>
+          </a:xfrm>
+          <a:prstGeom prst="rect">
+            <a:avLst/>
+          </a:prstGeom>
+          <a:extLst>
+            <a:ext uri="{C572A759-6A51-4108-AA02-DFA0A04FC94B}">
+              <ma14:wrappingTextBoxFlag xmlns:ma14="http://schemas.microsoft.com/office/mac/drawingml/2011/main" val="0"/>
+            </a:ext>
+          </a:extLst>
+        </p:spPr>
+        <p:txBody>
+          <a:bodyPr/>
+          <a:lstStyle>
+            <a:lvl1pPr>
+              <a:defRPr sz="700">
+                <a:solidFill>
+                  <a:srgbClr val="64748B"/>
+                </a:solidFill>
+                <a:latin typeface="Aptos"/>
+                <a:ea typeface="Aptos"/>
+                <a:cs typeface="Aptos"/>
+              </a:defRPr>
+            </a:lvl1pPr>
+          </a:lstStyle>
+          <a:p>
+            <a:pPr algn="l"/>
+            <a:fld id="{F7021451-1387-4CA6-816F-3879F97B5CBC}" type="slidenum">
+              <a:rPr b="0" lang="en-US"/>
+              <a:t>7</a:t>
+            </a:fld>
+            <a:endParaRPr lang="en-US"/>
+          </a:p>
+        </p:txBody>
+      </p:sp>
+    </p:spTree>
+  </p:cSld>
+  <p:clrMapOvr>
+    <a:masterClrMapping/>
+  </p:clrMapOvr>
+</p:sld>
+</file>
+
+<file path=ppt/slides/slide8.xml><?xml version="1.0" encoding="utf-8"?>
+<p:sld xmlns:a="http://schemas.openxmlformats.org/drawingml/2006/main" xmlns:r="http://schemas.openxmlformats.org/officeDocument/2006/relationships" xmlns:p="http://schemas.openxmlformats.org/presentationml/2006/main">
+  <p:cSld name="Slide 8">
+    <p:bg>
+      <p:bgPr>
+        <a:solidFill>
+          <a:srgbClr val="F8FAFC"/>
+        </a:solidFill>
+      </p:bgPr>
+    </p:bg>
+    <p:spTree>
+      <p:nvGrpSpPr>
+        <p:cNvPr id="1" name=""/>
+        <p:cNvGrpSpPr/>
+        <p:nvPr/>
+      </p:nvGrpSpPr>
+      <p:grpSpPr>
+        <a:xfrm>
+          <a:off x="0" y="0"/>
+          <a:ext cx="0" cy="0"/>
+          <a:chOff x="0" y="0"/>
+          <a:chExt cx="0" cy="0"/>
+        </a:xfrm>
+      </p:grpSpPr>
+      <p:sp>
+        <p:nvSpPr>
+          <p:cNvPr id="2" name="Text 0"/>
+          <p:cNvSpPr/>
+          <p:nvPr/>
+        </p:nvSpPr>
+        <p:spPr>
+          <a:xfrm>
+            <a:off x="566928" y="384048"/>
+            <a:ext cx="8686800" cy="201168"/>
+          </a:xfrm>
+          <a:prstGeom prst="rect">
+            <a:avLst/>
+          </a:prstGeom>
+          <a:noFill/>
+          <a:ln/>
+        </p:spPr>
+        <p:txBody>
+          <a:bodyPr wrap="square" lIns="0" tIns="0" rIns="0" bIns="0" rtlCol="0" anchor="ctr"/>
+          <a:lstStyle/>
+          <a:p>
+            <a:pPr indent="0" marL="0">
+              <a:buNone/>
+            </a:pPr>
+            <a:r>
+              <a:rPr lang="en-US" sz="800" b="1" dirty="0">
+                <a:solidFill>
+                  <a:srgbClr val="0F766E"/>
+                </a:solidFill>
+                <a:latin typeface="Aptos" pitchFamily="34" charset="0"/>
+                <a:ea typeface="Aptos" pitchFamily="34" charset="-122"/>
+                <a:cs typeface="Aptos" pitchFamily="34" charset="-120"/>
+              </a:rPr>
+              <a:t>WI-09 - PROTOTYPE TO PRODUCTION</a:t>
+            </a:r>
+            <a:endParaRPr lang="en-US" sz="800" dirty="0"/>
+          </a:p>
+        </p:txBody>
+      </p:sp>
+      <p:sp>
+        <p:nvSpPr>
+          <p:cNvPr id="3" name="Text 1"/>
+          <p:cNvSpPr/>
+          <p:nvPr/>
+        </p:nvSpPr>
+        <p:spPr>
+          <a:xfrm>
+            <a:off x="548640" y="658368"/>
+            <a:ext cx="10972800" cy="502920"/>
+          </a:xfrm>
+          <a:prstGeom prst="rect">
+            <a:avLst/>
+          </a:prstGeom>
+          <a:noFill/>
+          <a:ln/>
+        </p:spPr>
+        <p:txBody>
+          <a:bodyPr wrap="square" lIns="0" tIns="0" rIns="0" bIns="0" rtlCol="0" anchor="ctr">
+            <a:normAutofit/>
+          </a:bodyPr>
+          <a:lstStyle/>
+          <a:p>
+            <a:pPr indent="0" marL="0">
+              <a:buNone/>
+            </a:pPr>
+            <a:r>
+              <a:rPr lang="en-US" sz="2400" b="1" dirty="0">
+                <a:solidFill>
+                  <a:srgbClr val="0B1220"/>
+                </a:solidFill>
+                <a:latin typeface="Aptos Display" pitchFamily="34" charset="0"/>
+                <a:ea typeface="Aptos Display" pitchFamily="34" charset="-122"/>
+                <a:cs typeface="Aptos Display" pitchFamily="34" charset="-120"/>
+              </a:rPr>
+              <a:t>CI/CD: staged hybrid (local to GitHub Actions)</a:t>
+            </a:r>
+            <a:endParaRPr lang="en-US" sz="2400" dirty="0"/>
+          </a:p>
+        </p:txBody>
+      </p:sp>
+      <p:sp>
+        <p:nvSpPr>
+          <p:cNvPr id="4" name="Shape 2"/>
+          <p:cNvSpPr/>
+          <p:nvPr/>
+        </p:nvSpPr>
+        <p:spPr>
+          <a:xfrm>
+            <a:off x="548640" y="1243584"/>
+            <a:ext cx="11064240" cy="0"/>
+          </a:xfrm>
+          <a:prstGeom prst="line">
+            <a:avLst/>
+          </a:prstGeom>
+          <a:noFill/>
+          <a:ln w="12700">
+            <a:solidFill>
+              <a:srgbClr val="CBD5E1"/>
+            </a:solidFill>
+            <a:prstDash val="solid"/>
+          </a:ln>
+        </p:spPr>
+      </p:sp>
+      <p:sp>
+        <p:nvSpPr>
+          <p:cNvPr id="5" name="Shape 3"/>
+          <p:cNvSpPr/>
+          <p:nvPr/>
+        </p:nvSpPr>
+        <p:spPr>
+          <a:xfrm>
+            <a:off x="640080" y="1463040"/>
+            <a:ext cx="3520440" cy="1828800"/>
+          </a:xfrm>
+          <a:prstGeom prst="roundRect">
+            <a:avLst>
+              <a:gd name="adj" fmla="val 4000"/>
+            </a:avLst>
+          </a:prstGeom>
+          <a:solidFill>
+            <a:srgbClr val="FFFFFF"/>
+          </a:solidFill>
+          <a:ln w="12700">
+            <a:solidFill>
+              <a:srgbClr val="E2E8F0"/>
+            </a:solidFill>
+            <a:prstDash val="solid"/>
+          </a:ln>
+          <a:effectLst>
+            <a:outerShdw sx="100000" sy="100000" kx="0" ky="0" algn="bl" rotWithShape="0" blurRad="25400" dist="50800" dir="2700000">
+              <a:srgbClr val="94A3B8">
+                <a:alpha val="12000"/>
+              </a:srgbClr>
+            </a:outerShdw>
+          </a:effectLst>
+        </p:spPr>
+      </p:sp>
+      <p:sp>
+        <p:nvSpPr>
+          <p:cNvPr id="6" name="Shape 4"/>
+          <p:cNvSpPr/>
+          <p:nvPr/>
+        </p:nvSpPr>
+        <p:spPr>
+          <a:xfrm>
+            <a:off x="640080" y="1463040"/>
+            <a:ext cx="64008" cy="1828800"/>
+          </a:xfrm>
+          <a:prstGeom prst="rect">
+            <a:avLst/>
+          </a:prstGeom>
+          <a:solidFill>
+            <a:srgbClr val="2563EB"/>
+          </a:solidFill>
+          <a:ln w="12700">
+            <a:solidFill>
+              <a:srgbClr val="2563EB"/>
+            </a:solidFill>
+            <a:prstDash val="solid"/>
+          </a:ln>
+        </p:spPr>
+      </p:sp>
+      <p:sp>
+        <p:nvSpPr>
+          <p:cNvPr id="7" name="Text 5"/>
+          <p:cNvSpPr/>
+          <p:nvPr/>
+        </p:nvSpPr>
+        <p:spPr>
+          <a:xfrm>
+            <a:off x="841248" y="1609344"/>
+            <a:ext cx="3200400" cy="219456"/>
+          </a:xfrm>
+          <a:prstGeom prst="rect">
+            <a:avLst/>
+          </a:prstGeom>
+          <a:noFill/>
+          <a:ln/>
+        </p:spPr>
+        <p:txBody>
+          <a:bodyPr wrap="square" lIns="0" tIns="0" rIns="0" bIns="0" rtlCol="0" anchor="ctr">
+            <a:normAutofit/>
+          </a:bodyPr>
+          <a:lstStyle/>
+          <a:p>
+            <a:pPr indent="0" marL="0">
+              <a:buNone/>
+            </a:pPr>
+            <a:r>
+              <a:rPr lang="en-US" sz="1200" b="1" dirty="0">
+                <a:solidFill>
+                  <a:srgbClr val="0B1220"/>
+                </a:solidFill>
+                <a:latin typeface="Aptos" pitchFamily="34" charset="0"/>
+                <a:ea typeface="Aptos" pitchFamily="34" charset="-122"/>
+                <a:cs typeface="Aptos" pitchFamily="34" charset="-120"/>
+              </a:rPr>
+              <a:t>Stage 1 - prove it</a:t>
+            </a:r>
+            <a:endParaRPr lang="en-US" sz="1200" dirty="0"/>
+          </a:p>
+        </p:txBody>
+      </p:sp>
+      <p:sp>
+        <p:nvSpPr>
+          <p:cNvPr id="8" name="Text 6"/>
+          <p:cNvSpPr/>
+          <p:nvPr/>
+        </p:nvSpPr>
+        <p:spPr>
+          <a:xfrm>
+            <a:off x="841248" y="1920240"/>
+            <a:ext cx="3200400" cy="1280160"/>
+          </a:xfrm>
+          <a:prstGeom prst="rect">
+            <a:avLst/>
+          </a:prstGeom>
+          <a:noFill/>
+          <a:ln/>
+        </p:spPr>
+        <p:txBody>
+          <a:bodyPr wrap="square" lIns="254" tIns="254" rIns="254" bIns="254" rtlCol="0" anchor="t">
+            <a:normAutofit/>
+          </a:bodyPr>
+          <a:lstStyle/>
+          <a:p>
+            <a:pPr indent="0" marL="0">
+              <a:buNone/>
+            </a:pPr>
+            <a:r>
+              <a:rPr lang="en-US" sz="920" dirty="0">
+                <a:solidFill>
+                  <a:srgbClr val="334155"/>
+                </a:solidFill>
+                <a:latin typeface="Aptos" pitchFamily="34" charset="0"/>
+                <a:ea typeface="Aptos" pitchFamily="34" charset="-122"/>
+                <a:cs typeface="Aptos" pitchFamily="34" charset="-120"/>
+              </a:rPr>
+              <a:t>Local terraform apply (scripts/deploy.ps1) with local state and az login. One operator confirms the infra stands up end to end.</a:t>
+            </a:r>
+            <a:endParaRPr lang="en-US" sz="920" dirty="0"/>
+          </a:p>
+        </p:txBody>
+      </p:sp>
+      <p:sp>
+        <p:nvSpPr>
+          <p:cNvPr id="9" name="Shape 7"/>
+          <p:cNvSpPr/>
+          <p:nvPr/>
+        </p:nvSpPr>
+        <p:spPr>
+          <a:xfrm>
+            <a:off x="4343400" y="1463040"/>
+            <a:ext cx="3520440" cy="1828800"/>
+          </a:xfrm>
+          <a:prstGeom prst="roundRect">
+            <a:avLst>
+              <a:gd name="adj" fmla="val 4000"/>
+            </a:avLst>
+          </a:prstGeom>
+          <a:solidFill>
+            <a:srgbClr val="FFFFFF"/>
+          </a:solidFill>
+          <a:ln w="12700">
+            <a:solidFill>
+              <a:srgbClr val="E2E8F0"/>
+            </a:solidFill>
+            <a:prstDash val="solid"/>
+          </a:ln>
+          <a:effectLst>
+            <a:outerShdw sx="100000" sy="100000" kx="0" ky="0" algn="bl" rotWithShape="0" blurRad="25400" dist="50800" dir="2700000">
+              <a:srgbClr val="94A3B8">
+                <a:alpha val="12000"/>
+              </a:srgbClr>
+            </a:outerShdw>
+          </a:effectLst>
+        </p:spPr>
+      </p:sp>
+      <p:sp>
+        <p:nvSpPr>
+          <p:cNvPr id="10" name="Shape 8"/>
+          <p:cNvSpPr/>
+          <p:nvPr/>
+        </p:nvSpPr>
+        <p:spPr>
+          <a:xfrm>
+            <a:off x="4343400" y="1463040"/>
+            <a:ext cx="64008" cy="1828800"/>
+          </a:xfrm>
+          <a:prstGeom prst="rect">
+            <a:avLst/>
+          </a:prstGeom>
+          <a:solidFill>
+            <a:srgbClr val="F59E0B"/>
+          </a:solidFill>
+          <a:ln w="12700">
+            <a:solidFill>
+              <a:srgbClr val="F59E0B"/>
+            </a:solidFill>
+            <a:prstDash val="solid"/>
+          </a:ln>
+        </p:spPr>
+      </p:sp>
+      <p:sp>
+        <p:nvSpPr>
+          <p:cNvPr id="11" name="Text 9"/>
+          <p:cNvSpPr/>
+          <p:nvPr/>
+        </p:nvSpPr>
+        <p:spPr>
+          <a:xfrm>
+            <a:off x="4544568" y="1609344"/>
+            <a:ext cx="3200400" cy="219456"/>
+          </a:xfrm>
+          <a:prstGeom prst="rect">
+            <a:avLst/>
+          </a:prstGeom>
+          <a:noFill/>
+          <a:ln/>
+        </p:spPr>
+        <p:txBody>
+          <a:bodyPr wrap="square" lIns="0" tIns="0" rIns="0" bIns="0" rtlCol="0" anchor="ctr">
+            <a:normAutofit/>
+          </a:bodyPr>
+          <a:lstStyle/>
+          <a:p>
+            <a:pPr indent="0" marL="0">
+              <a:buNone/>
+            </a:pPr>
+            <a:r>
+              <a:rPr lang="en-US" sz="1200" b="1" dirty="0">
+                <a:solidFill>
+                  <a:srgbClr val="0B1220"/>
+                </a:solidFill>
+                <a:latin typeface="Aptos" pitchFamily="34" charset="0"/>
+                <a:ea typeface="Aptos" pitchFamily="34" charset="-122"/>
+                <a:cs typeface="Aptos" pitchFamily="34" charset="-120"/>
+              </a:rPr>
+              <a:t>Stage 2 - bootstrap</a:t>
+            </a:r>
+            <a:endParaRPr lang="en-US" sz="1200" dirty="0"/>
+          </a:p>
+        </p:txBody>
+      </p:sp>
+      <p:sp>
+        <p:nvSpPr>
+          <p:cNvPr id="12" name="Text 10"/>
+          <p:cNvSpPr/>
+          <p:nvPr/>
+        </p:nvSpPr>
+        <p:spPr>
+          <a:xfrm>
+            <a:off x="4544568" y="1920240"/>
+            <a:ext cx="3200400" cy="1280160"/>
+          </a:xfrm>
+          <a:prstGeom prst="rect">
+            <a:avLst/>
+          </a:prstGeom>
+          <a:noFill/>
+          <a:ln/>
+        </p:spPr>
+        <p:txBody>
+          <a:bodyPr wrap="square" lIns="254" tIns="254" rIns="254" bIns="254" rtlCol="0" anchor="t">
+            <a:normAutofit/>
+          </a:bodyPr>
+          <a:lstStyle/>
+          <a:p>
+            <a:pPr indent="0" marL="0">
+              <a:buNone/>
+            </a:pPr>
+            <a:r>
+              <a:rPr lang="en-US" sz="920" dirty="0">
+                <a:solidFill>
+                  <a:srgbClr val="334155"/>
+                </a:solidFill>
+                <a:latin typeface="Aptos" pitchFamily="34" charset="0"/>
+                <a:ea typeface="Aptos" pitchFamily="34" charset="-122"/>
+                <a:cs typeface="Aptos" pitchFamily="34" charset="-120"/>
+              </a:rPr>
+              <a:t>One-time, local: bootstrap-remote-state.ps1 creates the Azure blob state backend; setup-github-oidc.ps1 federates GitHub to Azure (keyless, no secret).</a:t>
+            </a:r>
+            <a:endParaRPr lang="en-US" sz="920" dirty="0"/>
+          </a:p>
+        </p:txBody>
+      </p:sp>
+      <p:sp>
+        <p:nvSpPr>
+          <p:cNvPr id="13" name="Shape 11"/>
+          <p:cNvSpPr/>
+          <p:nvPr/>
+        </p:nvSpPr>
+        <p:spPr>
+          <a:xfrm>
+            <a:off x="8046720" y="1463040"/>
+            <a:ext cx="3520440" cy="1828800"/>
+          </a:xfrm>
+          <a:prstGeom prst="roundRect">
+            <a:avLst>
+              <a:gd name="adj" fmla="val 4000"/>
+            </a:avLst>
+          </a:prstGeom>
+          <a:solidFill>
+            <a:srgbClr val="FFFFFF"/>
+          </a:solidFill>
+          <a:ln w="12700">
+            <a:solidFill>
+              <a:srgbClr val="E2E8F0"/>
+            </a:solidFill>
+            <a:prstDash val="solid"/>
+          </a:ln>
+          <a:effectLst>
+            <a:outerShdw sx="100000" sy="100000" kx="0" ky="0" algn="bl" rotWithShape="0" blurRad="25400" dist="50800" dir="2700000">
+              <a:srgbClr val="94A3B8">
+                <a:alpha val="12000"/>
+              </a:srgbClr>
+            </a:outerShdw>
+          </a:effectLst>
+        </p:spPr>
+      </p:sp>
+      <p:sp>
+        <p:nvSpPr>
+          <p:cNvPr id="14" name="Shape 12"/>
+          <p:cNvSpPr/>
+          <p:nvPr/>
+        </p:nvSpPr>
+        <p:spPr>
+          <a:xfrm>
+            <a:off x="8046720" y="1463040"/>
+            <a:ext cx="64008" cy="1828800"/>
+          </a:xfrm>
+          <a:prstGeom prst="rect">
+            <a:avLst/>
+          </a:prstGeom>
+          <a:solidFill>
+            <a:srgbClr val="16A34A"/>
+          </a:solidFill>
+          <a:ln w="12700">
+            <a:solidFill>
+              <a:srgbClr val="16A34A"/>
+            </a:solidFill>
+            <a:prstDash val="solid"/>
+          </a:ln>
+        </p:spPr>
+      </p:sp>
+      <p:sp>
+        <p:nvSpPr>
+          <p:cNvPr id="15" name="Text 13"/>
+          <p:cNvSpPr/>
+          <p:nvPr/>
+        </p:nvSpPr>
+        <p:spPr>
+          <a:xfrm>
+            <a:off x="8247888" y="1609344"/>
+            <a:ext cx="3200400" cy="219456"/>
+          </a:xfrm>
+          <a:prstGeom prst="rect">
+            <a:avLst/>
+          </a:prstGeom>
+          <a:noFill/>
+          <a:ln/>
+        </p:spPr>
+        <p:txBody>
+          <a:bodyPr wrap="square" lIns="0" tIns="0" rIns="0" bIns="0" rtlCol="0" anchor="ctr">
+            <a:normAutofit/>
+          </a:bodyPr>
+          <a:lstStyle/>
+          <a:p>
+            <a:pPr indent="0" marL="0">
+              <a:buNone/>
+            </a:pPr>
+            <a:r>
+              <a:rPr lang="en-US" sz="1200" b="1" dirty="0">
+                <a:solidFill>
+                  <a:srgbClr val="0B1220"/>
+                </a:solidFill>
+                <a:latin typeface="Aptos" pitchFamily="34" charset="0"/>
+                <a:ea typeface="Aptos" pitchFamily="34" charset="-122"/>
+                <a:cs typeface="Aptos" pitchFamily="34" charset="-120"/>
+              </a:rPr>
+              <a:t>Stage 3 - steady state</a:t>
+            </a:r>
+            <a:endParaRPr lang="en-US" sz="1200" dirty="0"/>
+          </a:p>
+        </p:txBody>
+      </p:sp>
+      <p:sp>
+        <p:nvSpPr>
+          <p:cNvPr id="16" name="Text 14"/>
+          <p:cNvSpPr/>
+          <p:nvPr/>
+        </p:nvSpPr>
+        <p:spPr>
+          <a:xfrm>
+            <a:off x="8247888" y="1920240"/>
+            <a:ext cx="3200400" cy="1280160"/>
+          </a:xfrm>
+          <a:prstGeom prst="rect">
+            <a:avLst/>
+          </a:prstGeom>
+          <a:noFill/>
+          <a:ln/>
+        </p:spPr>
+        <p:txBody>
+          <a:bodyPr wrap="square" lIns="254" tIns="254" rIns="254" bIns="254" rtlCol="0" anchor="t">
+            <a:normAutofit/>
+          </a:bodyPr>
+          <a:lstStyle/>
+          <a:p>
+            <a:pPr indent="0" marL="0">
+              <a:buNone/>
+            </a:pPr>
+            <a:r>
+              <a:rPr lang="en-US" sz="920" dirty="0">
+                <a:solidFill>
+                  <a:srgbClr val="334155"/>
+                </a:solidFill>
+                <a:latin typeface="Aptos" pitchFamily="34" charset="0"/>
+                <a:ea typeface="Aptos" pitchFamily="34" charset="-122"/>
+                <a:cs typeface="Aptos" pitchFamily="34" charset="-120"/>
+              </a:rPr>
+              <a:t>GitHub Actions: PR runs terraform plan (read-only); merge to main runs a human-gated apply on the 'production' environment. Remote state, OIDC.</a:t>
+            </a:r>
+            <a:endParaRPr lang="en-US" sz="920" dirty="0"/>
+          </a:p>
+        </p:txBody>
+      </p:sp>
+      <p:sp>
+        <p:nvSpPr>
+          <p:cNvPr id="17" name="Text 15"/>
+          <p:cNvSpPr/>
+          <p:nvPr/>
+        </p:nvSpPr>
+        <p:spPr>
+          <a:xfrm>
+            <a:off x="640080" y="3474720"/>
+            <a:ext cx="10972800" cy="1737360"/>
+          </a:xfrm>
+          <a:prstGeom prst="rect">
+            <a:avLst/>
+          </a:prstGeom>
+          <a:noFill/>
+          <a:ln/>
+        </p:spPr>
+        <p:txBody>
+          <a:bodyPr wrap="square" lIns="381" tIns="381" rIns="381" bIns="381" rtlCol="0" anchor="ctr">
+            <a:normAutofit/>
+          </a:bodyPr>
+          <a:lstStyle/>
+          <a:p>
+            <a:pPr marL="152400" indent="-152400">
+              <a:buSzPct val="100000"/>
+              <a:buChar char="•"/>
+            </a:pPr>
+            <a:r>
+              <a:rPr lang="en-US" sz="1150" dirty="0">
+                <a:solidFill>
+                  <a:srgbClr val="334155"/>
+                </a:solidFill>
+                <a:latin typeface="Aptos" pitchFamily="34" charset="0"/>
+                <a:ea typeface="Aptos" pitchFamily="34" charset="-122"/>
+                <a:cs typeface="Aptos" pitchFamily="34" charset="-120"/>
+              </a:rPr>
+              <a:t>Why staged: CI runners are stateless, so state must live in Azure and auth must be keyless (OIDC) - both created once in Stage 2 before CI can run.</a:t>
+            </a:r>
+            <a:endParaRPr lang="en-US" sz="1150" dirty="0"/>
+          </a:p>
+          <a:p>
+            <a:pPr marL="152400" indent="-152400">
+              <a:buSzPct val="100000"/>
+              <a:buChar char="•"/>
+            </a:pPr>
+            <a:r>
+              <a:rPr lang="en-US" sz="1150" dirty="0">
+                <a:solidFill>
+                  <a:srgbClr val="334155"/>
+                </a:solidFill>
+                <a:latin typeface="Aptos" pitchFamily="34" charset="0"/>
+                <a:ea typeface="Aptos" pitchFamily="34" charset="-122"/>
+                <a:cs typeface="Aptos" pitchFamily="34" charset="-120"/>
+              </a:rPr>
+              <a:t>ci.yml also runs the app build + tests + eval gate on every PR (no cloud). Workflows: .github/workflows/. Guide: infra/DEPLOYMENT.md.</a:t>
+            </a:r>
+            <a:endParaRPr lang="en-US" sz="1150" dirty="0"/>
+          </a:p>
+          <a:p>
+            <a:pPr marL="152400" indent="-152400">
+              <a:buSzPct val="100000"/>
+              <a:buChar char="•"/>
+            </a:pPr>
+            <a:r>
+              <a:rPr lang="en-US" sz="1150" dirty="0">
+                <a:solidFill>
+                  <a:srgbClr val="334155"/>
+                </a:solidFill>
+                <a:latin typeface="Aptos" pitchFamily="34" charset="0"/>
+                <a:ea typeface="Aptos" pitchFamily="34" charset="-122"/>
+                <a:cs typeface="Aptos" pitchFamily="34" charset="-120"/>
+              </a:rPr>
+              <a:t>No secrets committed: .env and backend.tf are gitignored; state/OIDC identifiers live in GitHub secrets/variables.</a:t>
+            </a:r>
+            <a:endParaRPr lang="en-US" sz="1150" dirty="0"/>
+          </a:p>
+        </p:txBody>
+      </p:sp>
+      <p:sp>
+        <p:nvSpPr>
+          <p:cNvPr id="18" name="Text 16"/>
+          <p:cNvSpPr/>
+          <p:nvPr/>
+        </p:nvSpPr>
+        <p:spPr>
+          <a:xfrm>
+            <a:off x="640080" y="5806440"/>
+            <a:ext cx="10972800" cy="457200"/>
+          </a:xfrm>
+          <a:prstGeom prst="rect">
+            <a:avLst/>
+          </a:prstGeom>
+          <a:noFill/>
+          <a:ln/>
+        </p:spPr>
+        <p:txBody>
+          <a:bodyPr wrap="square" lIns="0" tIns="0" rIns="0" bIns="0" rtlCol="0" anchor="ctr"/>
+          <a:lstStyle/>
+          <a:p>
+            <a:pPr indent="0" marL="0">
+              <a:buNone/>
+            </a:pPr>
+            <a:r>
+              <a:rPr lang="en-US" sz="1000" i="1" dirty="0">
+                <a:solidFill>
+                  <a:srgbClr val="64748B"/>
+                </a:solidFill>
+                <a:latin typeface="Aptos" pitchFamily="34" charset="0"/>
+                <a:ea typeface="Aptos" pitchFamily="34" charset="-122"/>
+                <a:cs typeface="Aptos" pitchFamily="34" charset="-120"/>
+              </a:rPr>
+              <a:t>Governance: apply is gated by an environment reviewer; roles (Contributor + User Access Administrator) can be scoped to a resource group. Plan-only is a safe workshop option.</a:t>
+            </a:r>
+            <a:endParaRPr lang="en-US" sz="1000" dirty="0"/>
+          </a:p>
+        </p:txBody>
+      </p:sp>
+      <p:sp>
+        <p:nvSpPr>
+          <p:cNvPr id="25" name="Slide Number Placeholder 0"/>
+          <p:cNvSpPr>
+            <a:spLocks noGrp="1"/>
+          </p:cNvSpPr>
+          <p:nvPr>
+            <p:ph type="sldNum" sz="quarter" idx="4294967295"/>
+          </p:nvPr>
+        </p:nvSpPr>
+        <p:spPr>
+          <a:xfrm>
+            <a:off x="11475720" y="6565392"/>
+            <a:ext cx="800000" cy="300000"/>
+          </a:xfrm>
+          <a:prstGeom prst="rect">
+            <a:avLst/>
+          </a:prstGeom>
+          <a:extLst>
+            <a:ext uri="{C572A759-6A51-4108-AA02-DFA0A04FC94B}">
+              <ma14:wrappingTextBoxFlag xmlns:ma14="http://schemas.microsoft.com/office/mac/drawingml/2011/main" val="0"/>
+            </a:ext>
+          </a:extLst>
+        </p:spPr>
+        <p:txBody>
+          <a:bodyPr/>
+          <a:lstStyle>
+            <a:lvl1pPr>
+              <a:defRPr sz="700">
+                <a:solidFill>
+                  <a:srgbClr val="64748B"/>
+                </a:solidFill>
+                <a:latin typeface="Aptos"/>
+                <a:ea typeface="Aptos"/>
+                <a:cs typeface="Aptos"/>
+              </a:defRPr>
+            </a:lvl1pPr>
+          </a:lstStyle>
+          <a:p>
+            <a:pPr algn="l"/>
+            <a:fld id="{F7021451-1387-4CA6-816F-3879F97B5CBC}" type="slidenum">
+              <a:rPr b="0" lang="en-US"/>
+              <a:t>8</a:t>
             </a:fld>
             <a:endParaRPr lang="en-US"/>
           </a:p>

</xml_diff>